<commit_message>
fix(review): align HOF duels and viewer with configs; correct stability claims and lockfile
</commit_message>
<xml_diff>
--- a/docs/presentation_deck.pptx
+++ b/docs/presentation_deck.pptx
@@ -4715,7 +4715,7 @@
                 <a:ea typeface="Calibri" pitchFamily="34" charset="-122"/>
                 <a:cs typeface="Calibri" pitchFamily="34" charset="-120"/>
               </a:rPr>
-              <a:t>248 tests green (3 Python versions x 3 OS in CI)   </a:t>
+              <a:t>251 tests green (3 Python versions on Ubuntu in CI)   </a:t>
             </a:r>
             <a:pPr indent="0" marL="0">
               <a:buNone/>
@@ -8330,7 +8330,7 @@
                 <a:ea typeface="Calibri" pitchFamily="34" charset="-122"/>
                 <a:cs typeface="Calibri" pitchFamily="34" charset="-120"/>
               </a:rPr>
-              <a:t>F9</a:t>
+              <a:t>SPACE pause</a:t>
             </a:r>
             <a:endParaRPr lang="en-US" sz="1700" dirty="0"/>
           </a:p>
@@ -8347,24 +8347,24 @@
                 <a:ea typeface="Calibri" pitchFamily="34" charset="-122"/>
                 <a:cs typeface="Calibri" pitchFamily="34" charset="-120"/>
               </a:rPr>
+              <a:t>F9 panel</a:t>
+            </a:r>
+            <a:endParaRPr lang="en-US" sz="1700" dirty="0"/>
+          </a:p>
+          <a:p>
+            <a:pPr algn="ctr" indent="0" marL="0">
+              <a:buNone/>
+            </a:pPr>
+            <a:r>
+              <a:rPr lang="en-US" sz="1700" dirty="0">
+                <a:solidFill>
+                  <a:srgbClr val="35C4D8"/>
+                </a:solidFill>
+                <a:latin typeface="Calibri" pitchFamily="34" charset="0"/>
+                <a:ea typeface="Calibri" pitchFamily="34" charset="-122"/>
+                <a:cs typeface="Calibri" pitchFamily="34" charset="-120"/>
+              </a:rPr>
               <a:t>click agent</a:t>
-            </a:r>
-            <a:endParaRPr lang="en-US" sz="1700" dirty="0"/>
-          </a:p>
-          <a:p>
-            <a:pPr algn="ctr" indent="0" marL="0">
-              <a:buNone/>
-            </a:pPr>
-            <a:r>
-              <a:rPr lang="en-US" sz="1700" dirty="0">
-                <a:solidFill>
-                  <a:srgbClr val="35C4D8"/>
-                </a:solidFill>
-                <a:latin typeface="Calibri" pitchFamily="34" charset="0"/>
-                <a:ea typeface="Calibri" pitchFamily="34" charset="-122"/>
-                <a:cs typeface="Calibri" pitchFamily="34" charset="-120"/>
-              </a:rPr>
-              <a:t>F for frame</a:t>
             </a:r>
             <a:endParaRPr lang="en-US" sz="1700" dirty="0"/>
           </a:p>

</xml_diff>